<commit_message>
Write up the stronger Forger study and the backend API; update the deck
</commit_message>
<xml_diff>
--- a/docs/GhostQPU_QHack_India26.pptx
+++ b/docs/GhostQPU_QHack_India26.pptx
@@ -12902,7 +12902,7 @@
                 </a:solidFill>
                 <a:latin typeface="IBM Plex Sans"/>
               </a:rPr>
-              <a:t>Limitation: </a:t>
+              <a:t>Smarter Forger: </a:t>
             </a:r>
             <a:r>
               <a:rPr sz="2200" b="0">
@@ -12911,7 +12911,7 @@
                 </a:solidFill>
                 <a:latin typeface="IBM Plex Sans"/>
               </a:rPr>
-              <a:t>a Forger that learns from one real job fooled the original Detector (scored 0.07, 0.11).</a:t>
+              <a:t>learning from a real job fooled the frozen Detector 12/13; retrained, caught 12/13.</a:t>
             </a:r>
           </a:p>
         </p:txBody>

</xml_diff>

<commit_message>
Add Tanvi's K8 kingston run, refresh all numbers, and commit the README art and deck generators
</commit_message>
<xml_diff>
--- a/docs/GhostQPU_QHack_India26.pptx
+++ b/docs/GhostQPU_QHack_India26.pptx
@@ -11632,7 +11632,7 @@
                 </a:solidFill>
                 <a:latin typeface="IBM Plex Sans"/>
               </a:rPr>
-              <a:t>23 jobs on ibm_marrakesh, ibm_fez and ibm_kingston over 18 calibration cycles and 4 days, each with a forged twin.</a:t>
+              <a:t>24 jobs on ibm_marrakesh, ibm_fez and ibm_kingston over 18 calibration cycles and 4 days, each with a forged twin.</a:t>
             </a:r>
           </a:p>
           <a:p>
@@ -12726,7 +12726,7 @@
                 </a:solidFill>
                 <a:latin typeface="IBM Plex Sans"/>
               </a:rPr>
-              <a:t>46 of 46 later jobs correct (23 real, 23 forged), 18 cycles, 3 machines.</a:t>
+              <a:t>48 of 48 later jobs correct (24 real, 24 forged), 18 cycles, 3 machines.</a:t>
             </a:r>
           </a:p>
           <a:p>
@@ -12763,7 +12763,7 @@
                 </a:solidFill>
                 <a:latin typeface="IBM Plex Sans"/>
               </a:rPr>
-              <a:t>AUC 1.00, 50 of 50 over 19 cycles. Trained only on earlier days: 46 of 46.</a:t>
+              <a:t>AUC 1.00, 52 of 52 over 19 cycles. Trained only on earlier days: 48 of 48.</a:t>
             </a:r>
           </a:p>
           <a:p>
@@ -12837,7 +12837,7 @@
                 </a:solidFill>
                 <a:latin typeface="IBM Plex Sans"/>
               </a:rPr>
-              <a:t>1.5 QPU seconds of canaries still calls all 50 jobs right.</a:t>
+              <a:t>1.5 QPU seconds of canaries still calls all 52 jobs right.</a:t>
             </a:r>
           </a:p>
           <a:p>

</xml_diff>

<commit_message>
Add four more jobs (30 total), the 10-job Detector and a full job list on the site, and polish the README
</commit_message>
<xml_diff>
--- a/docs/GhostQPU_QHack_India26.pptx
+++ b/docs/GhostQPU_QHack_India26.pptx
@@ -11632,7 +11632,7 @@
                 </a:solidFill>
                 <a:latin typeface="IBM Plex Sans"/>
               </a:rPr>
-              <a:t>24 jobs on ibm_marrakesh, ibm_fez and ibm_kingston over 18 calibration cycles and 4 days, each with a forged twin.</a:t>
+              <a:t>28 jobs on ibm_marrakesh, ibm_fez and ibm_kingston over 20 calibration cycles and 4 days, each with a forged twin.</a:t>
             </a:r>
           </a:p>
           <a:p>
@@ -12726,7 +12726,7 @@
                 </a:solidFill>
                 <a:latin typeface="IBM Plex Sans"/>
               </a:rPr>
-              <a:t>48 of 48 later jobs correct (24 real, 24 forged), 18 cycles, 3 machines.</a:t>
+              <a:t>56 of 56 later jobs correct (28 real, 28 forged), 20 cycles, 3 machines.</a:t>
             </a:r>
           </a:p>
           <a:p>
@@ -12763,7 +12763,7 @@
                 </a:solidFill>
                 <a:latin typeface="IBM Plex Sans"/>
               </a:rPr>
-              <a:t>AUC 1.00, 52 of 52 over 19 cycles. Trained only on earlier days: 48 of 48.</a:t>
+              <a:t>AUC 1.00, 60 of 60 over 21 cycles. Earlier days only: 56 of 56. Trained on 10 jobs: 40 of 40.</a:t>
             </a:r>
           </a:p>
           <a:p>
@@ -12837,7 +12837,7 @@
                 </a:solidFill>
                 <a:latin typeface="IBM Plex Sans"/>
               </a:rPr>
-              <a:t>1.5 QPU seconds of canaries still calls all 52 jobs right.</a:t>
+              <a:t>1.5 QPU seconds of canaries still calls all 60 jobs right.</a:t>
             </a:r>
           </a:p>
           <a:p>

</xml_diff>

<commit_message>
Fix slide text that wrapped out of its pills on the title and section slides
</commit_message>
<xml_diff>
--- a/docs/GhostQPU_QHack_India26.pptx
+++ b/docs/GhostQPU_QHack_India26.pptx
@@ -4359,7 +4359,7 @@
               </a:lnSpc>
             </a:pPr>
             <a:r>
-              <a:rPr lang="en-US" sz="3399">
+              <a:rPr lang="en-US" sz="3000">
                 <a:solidFill>
                   <a:srgbClr val="000000"/>
                 </a:solidFill>
@@ -4400,7 +4400,7 @@
               </a:lnSpc>
             </a:pPr>
             <a:r>
-              <a:rPr lang="en-US" sz="3599">
+              <a:rPr lang="en-US" sz="3000">
                 <a:solidFill>
                   <a:srgbClr val="000000"/>
                 </a:solidFill>
@@ -4441,7 +4441,7 @@
               </a:lnSpc>
             </a:pPr>
             <a:r>
-              <a:rPr lang="en-US" sz="3499">
+              <a:rPr lang="en-US" sz="3000">
                 <a:solidFill>
                   <a:srgbClr val="000000"/>
                 </a:solidFill>
@@ -4482,7 +4482,7 @@
               </a:lnSpc>
             </a:pPr>
             <a:r>
-              <a:rPr lang="en-US" sz="3499">
+              <a:rPr lang="en-US" sz="3000">
                 <a:solidFill>
                   <a:srgbClr val="000000"/>
                 </a:solidFill>
@@ -8481,8 +8481,8 @@
         </p:nvSpPr>
         <p:spPr>
           <a:xfrm>
-            <a:off x="7326063" y="1937259"/>
-            <a:ext cx="3027283" cy="497841"/>
+            <a:off x="6962023" y="1937259"/>
+            <a:ext cx="3755364" cy="497841"/>
           </a:xfrm>
           <a:prstGeom prst="rect">
             <a:avLst/>
@@ -9512,8 +9512,8 @@
         </p:nvSpPr>
         <p:spPr>
           <a:xfrm>
-            <a:off x="7514703" y="1963294"/>
-            <a:ext cx="2342555" cy="455296"/>
+            <a:off x="7451998" y="1963294"/>
+            <a:ext cx="2467965" cy="455296"/>
           </a:xfrm>
           <a:prstGeom prst="rect">
             <a:avLst/>
@@ -10508,8 +10508,8 @@
         </p:nvSpPr>
         <p:spPr>
           <a:xfrm>
-            <a:off x="6298992" y="1988059"/>
-            <a:ext cx="4566285" cy="405766"/>
+            <a:off x="5748676" y="1988059"/>
+            <a:ext cx="5666917" cy="405766"/>
           </a:xfrm>
           <a:prstGeom prst="rect">
             <a:avLst/>
@@ -12636,8 +12636,8 @@
         </p:nvSpPr>
         <p:spPr>
           <a:xfrm>
-            <a:off x="7550865" y="1969009"/>
-            <a:ext cx="2641044" cy="405766"/>
+            <a:off x="7043349" y="1969009"/>
+            <a:ext cx="3656076" cy="405766"/>
           </a:xfrm>
           <a:prstGeom prst="rect">
             <a:avLst/>

</xml_diff>